<commit_message>
add: ppt 양식 수정
</commit_message>
<xml_diff>
--- a/presentation/_PQC-Navy 미리보기 (1강).pptx
+++ b/presentation/_PQC-Navy 미리보기 (1강).pptx
@@ -3840,7 +3840,7 @@
               <a:lnSpc>
                 <a:spcPct val="150000"/>
               </a:lnSpc>
-              <a:defRPr sz="2000" b="0"/>
+              <a:defRPr sz="1800" b="0"/>
             </a:lvl1pPr>
             <a:lvl2pPr>
               <a:lnSpc>
@@ -3852,19 +3852,19 @@
               <a:lnSpc>
                 <a:spcPct val="150000"/>
               </a:lnSpc>
-              <a:defRPr sz="1600"/>
+              <a:defRPr sz="1800"/>
             </a:lvl3pPr>
             <a:lvl4pPr>
               <a:lnSpc>
                 <a:spcPct val="150000"/>
               </a:lnSpc>
-              <a:defRPr sz="1400"/>
+              <a:defRPr sz="1800"/>
             </a:lvl4pPr>
             <a:lvl5pPr>
               <a:lnSpc>
                 <a:spcPct val="150000"/>
               </a:lnSpc>
-              <a:defRPr sz="1400"/>
+              <a:defRPr sz="1800"/>
             </a:lvl5pPr>
           </a:lstStyle>
           <a:p>

</xml_diff>